<commit_message>
fix: complete headline metric provenance
</commit_message>
<xml_diff>
--- a/deliverables/TrustData_2026新域新质创新大赛路演稿.pptx
+++ b/deliverables/TrustData_2026新域新质创新大赛路演稿.pptx
@@ -2,24 +2,24 @@
 <file path=ppt/presentation.xml><?xml version="1.0" encoding="utf-8"?>
 <p:presentation xmlns:p="http://schemas.openxmlformats.org/presentationml/2006/main">
   <p:sldMasterIdLst>
-    <p:sldMasterId xmlns:r="http://schemas.openxmlformats.org/officeDocument/2006/relationships" id="2147483648" r:id="Reada4c07214a4fc5"/>
+    <p:sldMasterId xmlns:r="http://schemas.openxmlformats.org/officeDocument/2006/relationships" id="2147483648" r:id="R2b0e461ce8174783"/>
   </p:sldMasterIdLst>
   <p:notesMasterIdLst>
-    <p:notesMasterId xmlns:r="http://schemas.openxmlformats.org/officeDocument/2006/relationships" r:id="R577e6874eacf48bb"/>
+    <p:notesMasterId xmlns:r="http://schemas.openxmlformats.org/officeDocument/2006/relationships" r:id="Rb3fc853a63484e49"/>
   </p:notesMasterIdLst>
   <p:sldIdLst>
-    <p:sldId xmlns:r="http://schemas.openxmlformats.org/officeDocument/2006/relationships" id="256" r:id="R5f7cffe677134be6"/>
-    <p:sldId xmlns:r="http://schemas.openxmlformats.org/officeDocument/2006/relationships" id="257" r:id="Rc1dcf5dc7fec4a1d"/>
-    <p:sldId xmlns:r="http://schemas.openxmlformats.org/officeDocument/2006/relationships" id="258" r:id="Ra7eb9b978a3e4c14"/>
-    <p:sldId xmlns:r="http://schemas.openxmlformats.org/officeDocument/2006/relationships" id="259" r:id="R202e04e064d44773"/>
-    <p:sldId xmlns:r="http://schemas.openxmlformats.org/officeDocument/2006/relationships" id="260" r:id="R1e7b012933554dc8"/>
-    <p:sldId xmlns:r="http://schemas.openxmlformats.org/officeDocument/2006/relationships" id="261" r:id="R1ea83a3a477e45a7"/>
-    <p:sldId xmlns:r="http://schemas.openxmlformats.org/officeDocument/2006/relationships" id="262" r:id="R58ef54813b27436b"/>
-    <p:sldId xmlns:r="http://schemas.openxmlformats.org/officeDocument/2006/relationships" id="263" r:id="Rc84bcfba4023414c"/>
-    <p:sldId xmlns:r="http://schemas.openxmlformats.org/officeDocument/2006/relationships" id="264" r:id="Rb9f5cd10b6214d19"/>
-    <p:sldId xmlns:r="http://schemas.openxmlformats.org/officeDocument/2006/relationships" id="265" r:id="Re180aa2899ac4aec"/>
-    <p:sldId xmlns:r="http://schemas.openxmlformats.org/officeDocument/2006/relationships" id="266" r:id="Rbc398d50fdf34e08"/>
-    <p:sldId xmlns:r="http://schemas.openxmlformats.org/officeDocument/2006/relationships" id="267" r:id="R9885949bad75435f"/>
+    <p:sldId xmlns:r="http://schemas.openxmlformats.org/officeDocument/2006/relationships" id="256" r:id="R35bbcdff58b64e4e"/>
+    <p:sldId xmlns:r="http://schemas.openxmlformats.org/officeDocument/2006/relationships" id="257" r:id="R4bb93a8a84bc49dd"/>
+    <p:sldId xmlns:r="http://schemas.openxmlformats.org/officeDocument/2006/relationships" id="258" r:id="R94c34d6892d1498e"/>
+    <p:sldId xmlns:r="http://schemas.openxmlformats.org/officeDocument/2006/relationships" id="259" r:id="R53400c147cfe46ae"/>
+    <p:sldId xmlns:r="http://schemas.openxmlformats.org/officeDocument/2006/relationships" id="260" r:id="R59a336d4805e4c5d"/>
+    <p:sldId xmlns:r="http://schemas.openxmlformats.org/officeDocument/2006/relationships" id="261" r:id="R357a7a9d96dd46aa"/>
+    <p:sldId xmlns:r="http://schemas.openxmlformats.org/officeDocument/2006/relationships" id="262" r:id="Rd7493beb1e454658"/>
+    <p:sldId xmlns:r="http://schemas.openxmlformats.org/officeDocument/2006/relationships" id="263" r:id="R87960f4e58784326"/>
+    <p:sldId xmlns:r="http://schemas.openxmlformats.org/officeDocument/2006/relationships" id="264" r:id="R9cd2d5c0dc614dee"/>
+    <p:sldId xmlns:r="http://schemas.openxmlformats.org/officeDocument/2006/relationships" id="265" r:id="R675d301cb21f4023"/>
+    <p:sldId xmlns:r="http://schemas.openxmlformats.org/officeDocument/2006/relationships" id="266" r:id="Ra791c0a2b22a4dda"/>
+    <p:sldId xmlns:r="http://schemas.openxmlformats.org/officeDocument/2006/relationships" id="267" r:id="R3f52201e65ba4879"/>
   </p:sldIdLst>
   <p:sldSz cx="12192000" cy="6858000"/>
   <p:notesSz cx="6858000" cy="9144000"/>
@@ -1473,7 +1473,7 @@
           <a:lstStyle xmlns:a="http://schemas.openxmlformats.org/drawingml/2006/main"/>
           <a:p xmlns:a="http://schemas.openxmlformats.org/drawingml/2006/main">
             <a:r>
-              <a:t>平均排名误差与 Top-100 保留率分别报告。30% 污染下，原始平均排名误差为 20.3960，加权后为 15.2335，下降 25.31%；Spearman ρ 为 0.994，Top-100 overlap 为 0.70。加权排序在 20%—30% 污染下降低平均名次误差，在 5%—30% 污染下提高 Top-100 保留率；1% 污染下两项指标均下降，因此采用监测与人工复核策略。</a:t>
+              <a:t>平均排名误差与 Top-100 保留率分别报告。30% 污染下，原始平均排名误差为 20.3960，加权后为 15.2335，下降 25.31%；原始 Spearman ρ 为 0.993732，加权 Spearman ρ 为 0.993708（路演展示为 0.994）；原始 Top-100 overlap 为 0.66，加权后为 0.70。加权排序在 20%—30% 污染下降低平均名次误差，在 5%—30% 污染下提高 Top-100 保留率；1% 污染下两项指标均下降，因此采用监测与人工复核策略。</a:t>
             </a:r>
           </a:p>
           <a:p xmlns:a="http://schemas.openxmlformats.org/drawingml/2006/main">
@@ -1566,7 +1566,7 @@
   </p:cSld>
   <p:clrMap bg1="lt1" tx1="dk1" bg2="lt2" tx2="dk2" accent1="accent1" accent2="accent2" accent3="accent3" accent4="accent4" accent5="accent5" accent6="accent6" hlink="hlink" folHlink="folHlink"/>
   <p:sldLayoutIdLst>
-    <p:sldLayoutId xmlns:r="http://schemas.openxmlformats.org/officeDocument/2006/relationships" id="2147483649" r:id="R499e5cfb539849fc"/>
+    <p:sldLayoutId xmlns:r="http://schemas.openxmlformats.org/officeDocument/2006/relationships" id="2147483649" r:id="R4ee4e54996e8490c"/>
   </p:sldLayoutIdLst>
   <p:txStyles>
     <p:titleStyle>
@@ -14261,7 +14261,7 @@
           <p:nvPr/>
         </p:nvPicPr>
         <p:blipFill>
-          <a:blip xmlns:r="http://schemas.openxmlformats.org/officeDocument/2006/relationships" xmlns:a="http://schemas.openxmlformats.org/drawingml/2006/main" r:embed="R4132c619f3114f2c"/>
+          <a:blip xmlns:r="http://schemas.openxmlformats.org/officeDocument/2006/relationships" xmlns:a="http://schemas.openxmlformats.org/drawingml/2006/main" r:embed="R28a5da0e90c441f3"/>
           <a:stretch xmlns:a="http://schemas.openxmlformats.org/drawingml/2006/main">
             <a:fillRect l="0" t="0" r="0" b="0"/>
           </a:stretch>
@@ -14936,7 +14936,7 @@
           <p:nvPr/>
         </p:nvPicPr>
         <p:blipFill>
-          <a:blip xmlns:r="http://schemas.openxmlformats.org/officeDocument/2006/relationships" xmlns:a="http://schemas.openxmlformats.org/drawingml/2006/main" r:embed="R86ccb9034e1f40f0"/>
+          <a:blip xmlns:r="http://schemas.openxmlformats.org/officeDocument/2006/relationships" xmlns:a="http://schemas.openxmlformats.org/drawingml/2006/main" r:embed="R3d4ba7e2e509464b"/>
           <a:stretch xmlns:a="http://schemas.openxmlformats.org/drawingml/2006/main">
             <a:fillRect l="0" t="0" r="0" b="0"/>
           </a:stretch>
@@ -15078,7 +15078,7 @@
                 <a:ea typeface="Times New Roman"/>
                 <a:cs typeface="Times New Roman"/>
               </a:rPr>
-              <a:t>Spearman ρ  0.994</a:t>
+              <a:t>Weighted Spearman  0.994</a:t>
             </a:r>
             <a:endParaRPr sz="1950" b="1">
               <a:solidFill>
@@ -15113,7 +15113,7 @@
                 <a:ea typeface="Times New Roman"/>
                 <a:cs typeface="Times New Roman"/>
               </a:rPr>
-              <a:t>Top-100 overlap  0.70</a:t>
+              <a:t>Weighted Top-100  0.70</a:t>
             </a:r>
             <a:endParaRPr sz="1950" b="1">
               <a:solidFill>

</xml_diff>